<commit_message>
Redesign guide navigation and add xlsx dependency
Replaced guide sidebar with horizontal tab navigation and dropdowns.
Added xlsx package for spreadsheet processing.

Co-Authored-By: Claude Opus 4.6 <noreply@anthropic.com>
</commit_message>
<xml_diff>
--- a/apps/web/public/aoo-map.pptx
+++ b/apps/web/public/aoo-map.pptx
@@ -199,7 +199,7 @@
           <a:p>
             <a:fld id="{D1A7AE60-8256-F14E-9EB4-94FADFD335EB}" type="datetimeFigureOut">
               <a:rPr lang="en-US" smtClean="0"/>
-              <a:t>12/13/25</a:t>
+              <a:t>2/7/26</a:t>
             </a:fld>
             <a:endParaRPr lang="en-US"/>
           </a:p>
@@ -681,7 +681,7 @@
           <a:p>
             <a:fld id="{FDB6C4DE-B126-0B48-A37E-D4A228251755}" type="datetimeFigureOut">
               <a:rPr lang="en-US" smtClean="0"/>
-              <a:t>12/13/25</a:t>
+              <a:t>2/7/26</a:t>
             </a:fld>
             <a:endParaRPr lang="en-US"/>
           </a:p>
@@ -851,7 +851,7 @@
           <a:p>
             <a:fld id="{FDB6C4DE-B126-0B48-A37E-D4A228251755}" type="datetimeFigureOut">
               <a:rPr lang="en-US" smtClean="0"/>
-              <a:t>12/13/25</a:t>
+              <a:t>2/7/26</a:t>
             </a:fld>
             <a:endParaRPr lang="en-US"/>
           </a:p>
@@ -1031,7 +1031,7 @@
           <a:p>
             <a:fld id="{FDB6C4DE-B126-0B48-A37E-D4A228251755}" type="datetimeFigureOut">
               <a:rPr lang="en-US" smtClean="0"/>
-              <a:t>12/13/25</a:t>
+              <a:t>2/7/26</a:t>
             </a:fld>
             <a:endParaRPr lang="en-US"/>
           </a:p>
@@ -1201,7 +1201,7 @@
           <a:p>
             <a:fld id="{FDB6C4DE-B126-0B48-A37E-D4A228251755}" type="datetimeFigureOut">
               <a:rPr lang="en-US" smtClean="0"/>
-              <a:t>12/13/25</a:t>
+              <a:t>2/7/26</a:t>
             </a:fld>
             <a:endParaRPr lang="en-US"/>
           </a:p>
@@ -1447,7 +1447,7 @@
           <a:p>
             <a:fld id="{FDB6C4DE-B126-0B48-A37E-D4A228251755}" type="datetimeFigureOut">
               <a:rPr lang="en-US" smtClean="0"/>
-              <a:t>12/13/25</a:t>
+              <a:t>2/7/26</a:t>
             </a:fld>
             <a:endParaRPr lang="en-US"/>
           </a:p>
@@ -1679,7 +1679,7 @@
           <a:p>
             <a:fld id="{FDB6C4DE-B126-0B48-A37E-D4A228251755}" type="datetimeFigureOut">
               <a:rPr lang="en-US" smtClean="0"/>
-              <a:t>12/13/25</a:t>
+              <a:t>2/7/26</a:t>
             </a:fld>
             <a:endParaRPr lang="en-US"/>
           </a:p>
@@ -2046,7 +2046,7 @@
           <a:p>
             <a:fld id="{FDB6C4DE-B126-0B48-A37E-D4A228251755}" type="datetimeFigureOut">
               <a:rPr lang="en-US" smtClean="0"/>
-              <a:t>12/13/25</a:t>
+              <a:t>2/7/26</a:t>
             </a:fld>
             <a:endParaRPr lang="en-US"/>
           </a:p>
@@ -2164,7 +2164,7 @@
           <a:p>
             <a:fld id="{FDB6C4DE-B126-0B48-A37E-D4A228251755}" type="datetimeFigureOut">
               <a:rPr lang="en-US" smtClean="0"/>
-              <a:t>12/13/25</a:t>
+              <a:t>2/7/26</a:t>
             </a:fld>
             <a:endParaRPr lang="en-US"/>
           </a:p>
@@ -2259,7 +2259,7 @@
           <a:p>
             <a:fld id="{FDB6C4DE-B126-0B48-A37E-D4A228251755}" type="datetimeFigureOut">
               <a:rPr lang="en-US" smtClean="0"/>
-              <a:t>12/13/25</a:t>
+              <a:t>2/7/26</a:t>
             </a:fld>
             <a:endParaRPr lang="en-US"/>
           </a:p>
@@ -2536,7 +2536,7 @@
           <a:p>
             <a:fld id="{FDB6C4DE-B126-0B48-A37E-D4A228251755}" type="datetimeFigureOut">
               <a:rPr lang="en-US" smtClean="0"/>
-              <a:t>12/13/25</a:t>
+              <a:t>2/7/26</a:t>
             </a:fld>
             <a:endParaRPr lang="en-US"/>
           </a:p>
@@ -2793,7 +2793,7 @@
           <a:p>
             <a:fld id="{FDB6C4DE-B126-0B48-A37E-D4A228251755}" type="datetimeFigureOut">
               <a:rPr lang="en-US" smtClean="0"/>
-              <a:t>12/13/25</a:t>
+              <a:t>2/7/26</a:t>
             </a:fld>
             <a:endParaRPr lang="en-US"/>
           </a:p>
@@ -3006,7 +3006,7 @@
           <a:p>
             <a:fld id="{FDB6C4DE-B126-0B48-A37E-D4A228251755}" type="datetimeFigureOut">
               <a:rPr lang="en-US" smtClean="0"/>
-              <a:t>12/13/25</a:t>
+              <a:t>2/7/26</a:t>
             </a:fld>
             <a:endParaRPr lang="en-US"/>
           </a:p>
@@ -3462,7 +3462,7 @@
             <a:avLst/>
           </a:prstGeom>
           <a:solidFill>
-            <a:schemeClr val="accent1">
+            <a:schemeClr val="accent5">
               <a:alpha val="20000"/>
             </a:schemeClr>
           </a:solidFill>
@@ -3516,7 +3516,7 @@
             <a:avLst/>
           </a:prstGeom>
           <a:solidFill>
-            <a:schemeClr val="accent5">
+            <a:schemeClr val="accent4">
               <a:alpha val="20000"/>
             </a:schemeClr>
           </a:solidFill>
@@ -3600,6 +3600,710 @@
           <a:p>
             <a:pPr algn="ctr"/>
             <a:endParaRPr lang="en-US"/>
+          </a:p>
+        </p:txBody>
+      </p:sp>
+      <p:sp>
+        <p:nvSpPr>
+          <p:cNvPr id="2" name="TextBox 1">
+            <a:extLst>
+              <a:ext uri="{FF2B5EF4-FFF2-40B4-BE49-F238E27FC236}">
+                <a16:creationId xmlns:a16="http://schemas.microsoft.com/office/drawing/2014/main" id="{897E59F7-AE05-830E-6C93-61D3F48327EB}"/>
+              </a:ext>
+            </a:extLst>
+          </p:cNvPr>
+          <p:cNvSpPr txBox="1"/>
+          <p:nvPr/>
+        </p:nvSpPr>
+        <p:spPr>
+          <a:xfrm>
+            <a:off x="7268392" y="5347699"/>
+            <a:ext cx="934651" cy="519351"/>
+          </a:xfrm>
+          <a:prstGeom prst="ellipse">
+            <a:avLst/>
+          </a:prstGeom>
+          <a:solidFill>
+            <a:srgbClr val="FF0000"/>
+          </a:solidFill>
+          <a:effectLst>
+            <a:outerShdw blurRad="50800" dist="38100" dir="2700000" algn="tl" rotWithShape="0">
+              <a:prstClr val="black">
+                <a:alpha val="40000"/>
+              </a:prstClr>
+            </a:outerShdw>
+          </a:effectLst>
+        </p:spPr>
+        <p:txBody>
+          <a:bodyPr wrap="none" rtlCol="0">
+            <a:spAutoFit/>
+          </a:bodyPr>
+          <a:lstStyle/>
+          <a:p>
+            <a:r>
+              <a:rPr lang="en-US" dirty="0"/>
+              <a:t>Start</a:t>
+            </a:r>
+          </a:p>
+        </p:txBody>
+      </p:sp>
+      <p:sp>
+        <p:nvSpPr>
+          <p:cNvPr id="3" name="TextBox 2">
+            <a:extLst>
+              <a:ext uri="{FF2B5EF4-FFF2-40B4-BE49-F238E27FC236}">
+                <a16:creationId xmlns:a16="http://schemas.microsoft.com/office/drawing/2014/main" id="{D4F51FB2-A504-E958-2340-45080BFE8078}"/>
+              </a:ext>
+            </a:extLst>
+          </p:cNvPr>
+          <p:cNvSpPr txBox="1"/>
+          <p:nvPr/>
+        </p:nvSpPr>
+        <p:spPr>
+          <a:xfrm>
+            <a:off x="577331" y="496441"/>
+            <a:ext cx="1211548" cy="519351"/>
+          </a:xfrm>
+          <a:prstGeom prst="ellipse">
+            <a:avLst/>
+          </a:prstGeom>
+          <a:solidFill>
+            <a:schemeClr val="accent4"/>
+          </a:solidFill>
+          <a:effectLst>
+            <a:outerShdw blurRad="50800" dist="38100" dir="2700000" algn="tl" rotWithShape="0">
+              <a:prstClr val="black">
+                <a:alpha val="40000"/>
+              </a:prstClr>
+            </a:outerShdw>
+          </a:effectLst>
+        </p:spPr>
+        <p:txBody>
+          <a:bodyPr wrap="none" rtlCol="0">
+            <a:spAutoFit/>
+          </a:bodyPr>
+          <a:lstStyle/>
+          <a:p>
+            <a:r>
+              <a:rPr lang="en-US" dirty="0"/>
+              <a:t>Enemy</a:t>
+            </a:r>
+          </a:p>
+        </p:txBody>
+      </p:sp>
+      <p:cxnSp>
+        <p:nvCxnSpPr>
+          <p:cNvPr id="5" name="Straight Arrow Connector 4">
+            <a:extLst>
+              <a:ext uri="{FF2B5EF4-FFF2-40B4-BE49-F238E27FC236}">
+                <a16:creationId xmlns:a16="http://schemas.microsoft.com/office/drawing/2014/main" id="{CB966B82-6CA0-46E5-1E21-59115CE4C277}"/>
+              </a:ext>
+            </a:extLst>
+          </p:cNvPr>
+          <p:cNvCxnSpPr/>
+          <p:nvPr/>
+        </p:nvCxnSpPr>
+        <p:spPr>
+          <a:xfrm flipV="1">
+            <a:off x="7602279" y="3429000"/>
+            <a:ext cx="0" cy="1727791"/>
+          </a:xfrm>
+          <a:prstGeom prst="straightConnector1">
+            <a:avLst/>
+          </a:prstGeom>
+          <a:ln w="47625">
+            <a:solidFill>
+              <a:schemeClr val="accent4"/>
+            </a:solidFill>
+            <a:headEnd w="lg" len="lg"/>
+            <a:tailEnd type="arrow"/>
+          </a:ln>
+          <a:effectLst>
+            <a:outerShdw blurRad="50800" dist="38100" dir="2700000" algn="tl" rotWithShape="0">
+              <a:prstClr val="black">
+                <a:alpha val="40000"/>
+              </a:prstClr>
+            </a:outerShdw>
+          </a:effectLst>
+        </p:spPr>
+        <p:style>
+          <a:lnRef idx="2">
+            <a:schemeClr val="accent1"/>
+          </a:lnRef>
+          <a:fillRef idx="0">
+            <a:schemeClr val="accent1"/>
+          </a:fillRef>
+          <a:effectRef idx="1">
+            <a:schemeClr val="accent1"/>
+          </a:effectRef>
+          <a:fontRef idx="minor">
+            <a:schemeClr val="tx1"/>
+          </a:fontRef>
+        </p:style>
+      </p:cxnSp>
+      <p:cxnSp>
+        <p:nvCxnSpPr>
+          <p:cNvPr id="11" name="Straight Arrow Connector 10">
+            <a:extLst>
+              <a:ext uri="{FF2B5EF4-FFF2-40B4-BE49-F238E27FC236}">
+                <a16:creationId xmlns:a16="http://schemas.microsoft.com/office/drawing/2014/main" id="{0794881D-0240-C951-375B-FF2B22F66CC4}"/>
+              </a:ext>
+            </a:extLst>
+          </p:cNvPr>
+          <p:cNvCxnSpPr>
+            <a:cxnSpLocks/>
+          </p:cNvCxnSpPr>
+          <p:nvPr/>
+        </p:nvCxnSpPr>
+        <p:spPr>
+          <a:xfrm flipH="1" flipV="1">
+            <a:off x="4072270" y="5532365"/>
+            <a:ext cx="2955851" cy="156054"/>
+          </a:xfrm>
+          <a:prstGeom prst="straightConnector1">
+            <a:avLst/>
+          </a:prstGeom>
+          <a:ln w="47625">
+            <a:solidFill>
+              <a:schemeClr val="accent5"/>
+            </a:solidFill>
+            <a:headEnd w="lg" len="lg"/>
+            <a:tailEnd type="arrow"/>
+          </a:ln>
+          <a:effectLst>
+            <a:outerShdw blurRad="50800" dist="38100" dir="2700000" algn="tl" rotWithShape="0">
+              <a:prstClr val="black">
+                <a:alpha val="40000"/>
+              </a:prstClr>
+            </a:outerShdw>
+          </a:effectLst>
+        </p:spPr>
+        <p:style>
+          <a:lnRef idx="2">
+            <a:schemeClr val="accent1"/>
+          </a:lnRef>
+          <a:fillRef idx="0">
+            <a:schemeClr val="accent1"/>
+          </a:fillRef>
+          <a:effectRef idx="1">
+            <a:schemeClr val="accent1"/>
+          </a:effectRef>
+          <a:fontRef idx="minor">
+            <a:schemeClr val="tx1"/>
+          </a:fontRef>
+        </p:style>
+      </p:cxnSp>
+      <p:cxnSp>
+        <p:nvCxnSpPr>
+          <p:cNvPr id="12" name="Straight Arrow Connector 11">
+            <a:extLst>
+              <a:ext uri="{FF2B5EF4-FFF2-40B4-BE49-F238E27FC236}">
+                <a16:creationId xmlns:a16="http://schemas.microsoft.com/office/drawing/2014/main" id="{324A0CBB-F801-14CE-A390-1A2A6368810E}"/>
+              </a:ext>
+            </a:extLst>
+          </p:cNvPr>
+          <p:cNvCxnSpPr>
+            <a:cxnSpLocks/>
+          </p:cNvCxnSpPr>
+          <p:nvPr/>
+        </p:nvCxnSpPr>
+        <p:spPr>
+          <a:xfrm flipH="1" flipV="1">
+            <a:off x="6424004" y="2934586"/>
+            <a:ext cx="877383" cy="117322"/>
+          </a:xfrm>
+          <a:prstGeom prst="straightConnector1">
+            <a:avLst/>
+          </a:prstGeom>
+          <a:ln w="47625">
+            <a:solidFill>
+              <a:schemeClr val="accent4"/>
+            </a:solidFill>
+            <a:headEnd w="lg" len="lg"/>
+            <a:tailEnd type="arrow"/>
+          </a:ln>
+          <a:effectLst>
+            <a:outerShdw blurRad="50800" dist="38100" dir="2700000" algn="tl" rotWithShape="0">
+              <a:prstClr val="black">
+                <a:alpha val="40000"/>
+              </a:prstClr>
+            </a:outerShdw>
+          </a:effectLst>
+        </p:spPr>
+        <p:style>
+          <a:lnRef idx="2">
+            <a:schemeClr val="accent1"/>
+          </a:lnRef>
+          <a:fillRef idx="0">
+            <a:schemeClr val="accent1"/>
+          </a:fillRef>
+          <a:effectRef idx="1">
+            <a:schemeClr val="accent1"/>
+          </a:effectRef>
+          <a:fontRef idx="minor">
+            <a:schemeClr val="tx1"/>
+          </a:fontRef>
+        </p:style>
+      </p:cxnSp>
+      <p:cxnSp>
+        <p:nvCxnSpPr>
+          <p:cNvPr id="15" name="Straight Arrow Connector 14">
+            <a:extLst>
+              <a:ext uri="{FF2B5EF4-FFF2-40B4-BE49-F238E27FC236}">
+                <a16:creationId xmlns:a16="http://schemas.microsoft.com/office/drawing/2014/main" id="{73983888-8841-8D18-604F-0818EFC01CC8}"/>
+              </a:ext>
+            </a:extLst>
+          </p:cNvPr>
+          <p:cNvCxnSpPr>
+            <a:cxnSpLocks/>
+          </p:cNvCxnSpPr>
+          <p:nvPr/>
+        </p:nvCxnSpPr>
+        <p:spPr>
+          <a:xfrm flipH="1" flipV="1">
+            <a:off x="7301387" y="2211572"/>
+            <a:ext cx="268902" cy="606056"/>
+          </a:xfrm>
+          <a:prstGeom prst="straightConnector1">
+            <a:avLst/>
+          </a:prstGeom>
+          <a:ln w="47625">
+            <a:solidFill>
+              <a:schemeClr val="accent4"/>
+            </a:solidFill>
+            <a:headEnd w="lg" len="lg"/>
+            <a:tailEnd type="arrow"/>
+          </a:ln>
+          <a:effectLst>
+            <a:outerShdw blurRad="50800" dist="38100" dir="2700000" algn="tl" rotWithShape="0">
+              <a:prstClr val="black">
+                <a:alpha val="40000"/>
+              </a:prstClr>
+            </a:outerShdw>
+          </a:effectLst>
+        </p:spPr>
+        <p:style>
+          <a:lnRef idx="2">
+            <a:schemeClr val="accent1"/>
+          </a:lnRef>
+          <a:fillRef idx="0">
+            <a:schemeClr val="accent1"/>
+          </a:fillRef>
+          <a:effectRef idx="1">
+            <a:schemeClr val="accent1"/>
+          </a:effectRef>
+          <a:fontRef idx="minor">
+            <a:schemeClr val="tx1"/>
+          </a:fontRef>
+        </p:style>
+      </p:cxnSp>
+      <p:cxnSp>
+        <p:nvCxnSpPr>
+          <p:cNvPr id="19" name="Straight Arrow Connector 18">
+            <a:extLst>
+              <a:ext uri="{FF2B5EF4-FFF2-40B4-BE49-F238E27FC236}">
+                <a16:creationId xmlns:a16="http://schemas.microsoft.com/office/drawing/2014/main" id="{7AEEEA9F-6BC2-4D8A-5B86-779AEA5190CD}"/>
+              </a:ext>
+            </a:extLst>
+          </p:cNvPr>
+          <p:cNvCxnSpPr>
+            <a:cxnSpLocks/>
+          </p:cNvCxnSpPr>
+          <p:nvPr/>
+        </p:nvCxnSpPr>
+        <p:spPr>
+          <a:xfrm flipH="1" flipV="1">
+            <a:off x="2509284" y="5276956"/>
+            <a:ext cx="801321" cy="83918"/>
+          </a:xfrm>
+          <a:prstGeom prst="straightConnector1">
+            <a:avLst/>
+          </a:prstGeom>
+          <a:ln w="47625">
+            <a:solidFill>
+              <a:schemeClr val="accent5"/>
+            </a:solidFill>
+            <a:headEnd w="lg" len="lg"/>
+            <a:tailEnd type="arrow"/>
+          </a:ln>
+          <a:effectLst>
+            <a:outerShdw blurRad="50800" dist="38100" dir="2700000" algn="tl" rotWithShape="0">
+              <a:prstClr val="black">
+                <a:alpha val="40000"/>
+              </a:prstClr>
+            </a:outerShdw>
+          </a:effectLst>
+        </p:spPr>
+        <p:style>
+          <a:lnRef idx="2">
+            <a:schemeClr val="accent1"/>
+          </a:lnRef>
+          <a:fillRef idx="0">
+            <a:schemeClr val="accent1"/>
+          </a:fillRef>
+          <a:effectRef idx="1">
+            <a:schemeClr val="accent1"/>
+          </a:effectRef>
+          <a:fontRef idx="minor">
+            <a:schemeClr val="tx1"/>
+          </a:fontRef>
+        </p:style>
+      </p:cxnSp>
+      <p:cxnSp>
+        <p:nvCxnSpPr>
+          <p:cNvPr id="22" name="Straight Arrow Connector 21">
+            <a:extLst>
+              <a:ext uri="{FF2B5EF4-FFF2-40B4-BE49-F238E27FC236}">
+                <a16:creationId xmlns:a16="http://schemas.microsoft.com/office/drawing/2014/main" id="{AA9957DC-33DE-F67B-4C4C-34748D76AAC7}"/>
+              </a:ext>
+            </a:extLst>
+          </p:cNvPr>
+          <p:cNvCxnSpPr>
+            <a:cxnSpLocks/>
+          </p:cNvCxnSpPr>
+          <p:nvPr/>
+        </p:nvCxnSpPr>
+        <p:spPr>
+          <a:xfrm flipV="1">
+            <a:off x="3678865" y="4433777"/>
+            <a:ext cx="0" cy="723014"/>
+          </a:xfrm>
+          <a:prstGeom prst="straightConnector1">
+            <a:avLst/>
+          </a:prstGeom>
+          <a:ln w="47625">
+            <a:solidFill>
+              <a:schemeClr val="accent5"/>
+            </a:solidFill>
+            <a:headEnd w="lg" len="lg"/>
+            <a:tailEnd type="arrow"/>
+          </a:ln>
+          <a:effectLst>
+            <a:outerShdw blurRad="50800" dist="38100" dir="2700000" algn="tl" rotWithShape="0">
+              <a:prstClr val="black">
+                <a:alpha val="40000"/>
+              </a:prstClr>
+            </a:outerShdw>
+          </a:effectLst>
+        </p:spPr>
+        <p:style>
+          <a:lnRef idx="2">
+            <a:schemeClr val="accent1"/>
+          </a:lnRef>
+          <a:fillRef idx="0">
+            <a:schemeClr val="accent1"/>
+          </a:fillRef>
+          <a:effectRef idx="1">
+            <a:schemeClr val="accent1"/>
+          </a:effectRef>
+          <a:fontRef idx="minor">
+            <a:schemeClr val="tx1"/>
+          </a:fontRef>
+        </p:style>
+      </p:cxnSp>
+      <p:cxnSp>
+        <p:nvCxnSpPr>
+          <p:cNvPr id="25" name="Straight Arrow Connector 24">
+            <a:extLst>
+              <a:ext uri="{FF2B5EF4-FFF2-40B4-BE49-F238E27FC236}">
+                <a16:creationId xmlns:a16="http://schemas.microsoft.com/office/drawing/2014/main" id="{1B146A04-B288-17D0-9395-51BA9D58B940}"/>
+              </a:ext>
+            </a:extLst>
+          </p:cNvPr>
+          <p:cNvCxnSpPr>
+            <a:cxnSpLocks/>
+          </p:cNvCxnSpPr>
+          <p:nvPr/>
+        </p:nvCxnSpPr>
+        <p:spPr>
+          <a:xfrm flipH="1" flipV="1">
+            <a:off x="5819888" y="4240838"/>
+            <a:ext cx="1208233" cy="915953"/>
+          </a:xfrm>
+          <a:prstGeom prst="straightConnector1">
+            <a:avLst/>
+          </a:prstGeom>
+          <a:ln w="47625">
+            <a:solidFill>
+              <a:schemeClr val="accent2"/>
+            </a:solidFill>
+            <a:headEnd w="lg" len="lg"/>
+            <a:tailEnd type="arrow"/>
+          </a:ln>
+          <a:effectLst>
+            <a:outerShdw blurRad="50800" dist="38100" dir="2700000" algn="tl" rotWithShape="0">
+              <a:prstClr val="black">
+                <a:alpha val="40000"/>
+              </a:prstClr>
+            </a:outerShdw>
+          </a:effectLst>
+        </p:spPr>
+        <p:style>
+          <a:lnRef idx="2">
+            <a:schemeClr val="accent1"/>
+          </a:lnRef>
+          <a:fillRef idx="0">
+            <a:schemeClr val="accent1"/>
+          </a:fillRef>
+          <a:effectRef idx="1">
+            <a:schemeClr val="accent1"/>
+          </a:effectRef>
+          <a:fontRef idx="minor">
+            <a:schemeClr val="tx1"/>
+          </a:fontRef>
+        </p:style>
+      </p:cxnSp>
+      <p:cxnSp>
+        <p:nvCxnSpPr>
+          <p:cNvPr id="28" name="Straight Arrow Connector 27">
+            <a:extLst>
+              <a:ext uri="{FF2B5EF4-FFF2-40B4-BE49-F238E27FC236}">
+                <a16:creationId xmlns:a16="http://schemas.microsoft.com/office/drawing/2014/main" id="{D10C76C3-F41D-795D-AE09-E508DAA5BF9C}"/>
+              </a:ext>
+            </a:extLst>
+          </p:cNvPr>
+          <p:cNvCxnSpPr>
+            <a:cxnSpLocks/>
+          </p:cNvCxnSpPr>
+          <p:nvPr/>
+        </p:nvCxnSpPr>
+        <p:spPr>
+          <a:xfrm flipH="1">
+            <a:off x="5550195" y="4225401"/>
+            <a:ext cx="29422" cy="633181"/>
+          </a:xfrm>
+          <a:prstGeom prst="straightConnector1">
+            <a:avLst/>
+          </a:prstGeom>
+          <a:ln w="47625">
+            <a:solidFill>
+              <a:schemeClr val="accent2"/>
+            </a:solidFill>
+            <a:headEnd w="lg" len="lg"/>
+            <a:tailEnd type="arrow"/>
+          </a:ln>
+          <a:effectLst>
+            <a:outerShdw blurRad="50800" dist="38100" dir="2700000" algn="tl" rotWithShape="0">
+              <a:prstClr val="black">
+                <a:alpha val="40000"/>
+              </a:prstClr>
+            </a:outerShdw>
+          </a:effectLst>
+        </p:spPr>
+        <p:style>
+          <a:lnRef idx="2">
+            <a:schemeClr val="accent1"/>
+          </a:lnRef>
+          <a:fillRef idx="0">
+            <a:schemeClr val="accent1"/>
+          </a:fillRef>
+          <a:effectRef idx="1">
+            <a:schemeClr val="accent1"/>
+          </a:effectRef>
+          <a:fontRef idx="minor">
+            <a:schemeClr val="tx1"/>
+          </a:fontRef>
+        </p:style>
+      </p:cxnSp>
+      <p:cxnSp>
+        <p:nvCxnSpPr>
+          <p:cNvPr id="32" name="Straight Arrow Connector 31">
+            <a:extLst>
+              <a:ext uri="{FF2B5EF4-FFF2-40B4-BE49-F238E27FC236}">
+                <a16:creationId xmlns:a16="http://schemas.microsoft.com/office/drawing/2014/main" id="{28488E46-24D8-4A6F-74C5-EC4182A250E2}"/>
+              </a:ext>
+            </a:extLst>
+          </p:cNvPr>
+          <p:cNvCxnSpPr>
+            <a:cxnSpLocks/>
+          </p:cNvCxnSpPr>
+          <p:nvPr/>
+        </p:nvCxnSpPr>
+        <p:spPr>
+          <a:xfrm>
+            <a:off x="5768372" y="4005005"/>
+            <a:ext cx="906580" cy="0"/>
+          </a:xfrm>
+          <a:prstGeom prst="straightConnector1">
+            <a:avLst/>
+          </a:prstGeom>
+          <a:ln w="47625">
+            <a:solidFill>
+              <a:schemeClr val="accent2"/>
+            </a:solidFill>
+            <a:headEnd w="lg" len="lg"/>
+            <a:tailEnd type="arrow"/>
+          </a:ln>
+          <a:effectLst>
+            <a:outerShdw blurRad="50800" dist="38100" dir="2700000" algn="tl" rotWithShape="0">
+              <a:prstClr val="black">
+                <a:alpha val="40000"/>
+              </a:prstClr>
+            </a:outerShdw>
+          </a:effectLst>
+        </p:spPr>
+        <p:style>
+          <a:lnRef idx="2">
+            <a:schemeClr val="accent1"/>
+          </a:lnRef>
+          <a:fillRef idx="0">
+            <a:schemeClr val="accent1"/>
+          </a:fillRef>
+          <a:effectRef idx="1">
+            <a:schemeClr val="accent1"/>
+          </a:effectRef>
+          <a:fontRef idx="minor">
+            <a:schemeClr val="tx1"/>
+          </a:fontRef>
+        </p:style>
+      </p:cxnSp>
+      <p:sp>
+        <p:nvSpPr>
+          <p:cNvPr id="35" name="TextBox 34">
+            <a:extLst>
+              <a:ext uri="{FF2B5EF4-FFF2-40B4-BE49-F238E27FC236}">
+                <a16:creationId xmlns:a16="http://schemas.microsoft.com/office/drawing/2014/main" id="{D54C6507-5262-D089-7554-B42DE163F015}"/>
+              </a:ext>
+            </a:extLst>
+          </p:cNvPr>
+          <p:cNvSpPr txBox="1"/>
+          <p:nvPr/>
+        </p:nvSpPr>
+        <p:spPr>
+          <a:xfrm>
+            <a:off x="6621188" y="556458"/>
+            <a:ext cx="1665328" cy="646331"/>
+          </a:xfrm>
+          <a:prstGeom prst="rect">
+            <a:avLst/>
+          </a:prstGeom>
+          <a:noFill/>
+          <a:effectLst>
+            <a:outerShdw blurRad="50800" dist="38100" dir="2700000" algn="tl" rotWithShape="0">
+              <a:prstClr val="black">
+                <a:alpha val="40000"/>
+              </a:prstClr>
+            </a:outerShdw>
+          </a:effectLst>
+        </p:spPr>
+        <p:txBody>
+          <a:bodyPr wrap="none" rtlCol="0">
+            <a:spAutoFit/>
+          </a:bodyPr>
+          <a:lstStyle/>
+          <a:p>
+            <a:r>
+              <a:rPr lang="en-US" dirty="0"/>
+              <a:t>Top Lane:</a:t>
+            </a:r>
+          </a:p>
+          <a:p>
+            <a:r>
+              <a:rPr lang="en-US" dirty="0" err="1"/>
+              <a:t>GiaHuy’s</a:t>
+            </a:r>
+            <a:r>
+              <a:rPr lang="en-US" dirty="0"/>
+              <a:t> Team</a:t>
+            </a:r>
+          </a:p>
+        </p:txBody>
+      </p:sp>
+      <p:sp>
+        <p:nvSpPr>
+          <p:cNvPr id="36" name="TextBox 35">
+            <a:extLst>
+              <a:ext uri="{FF2B5EF4-FFF2-40B4-BE49-F238E27FC236}">
+                <a16:creationId xmlns:a16="http://schemas.microsoft.com/office/drawing/2014/main" id="{0EF2A187-0E41-22B5-D6F9-F99E80D3F9BB}"/>
+              </a:ext>
+            </a:extLst>
+          </p:cNvPr>
+          <p:cNvSpPr txBox="1"/>
+          <p:nvPr/>
+        </p:nvSpPr>
+        <p:spPr>
+          <a:xfrm>
+            <a:off x="1501009" y="5981968"/>
+            <a:ext cx="1526444" cy="646331"/>
+          </a:xfrm>
+          <a:prstGeom prst="rect">
+            <a:avLst/>
+          </a:prstGeom>
+          <a:noFill/>
+          <a:effectLst>
+            <a:outerShdw blurRad="50800" dist="38100" dir="2700000" algn="tl" rotWithShape="0">
+              <a:prstClr val="black">
+                <a:alpha val="40000"/>
+              </a:prstClr>
+            </a:outerShdw>
+          </a:effectLst>
+        </p:spPr>
+        <p:txBody>
+          <a:bodyPr wrap="none" rtlCol="0">
+            <a:spAutoFit/>
+          </a:bodyPr>
+          <a:lstStyle/>
+          <a:p>
+            <a:pPr algn="r"/>
+            <a:r>
+              <a:rPr lang="en-US" dirty="0"/>
+              <a:t>Bottom Lane:</a:t>
+            </a:r>
+          </a:p>
+          <a:p>
+            <a:pPr algn="r"/>
+            <a:r>
+              <a:rPr lang="en-US" dirty="0"/>
+              <a:t>Bun’s Team</a:t>
+            </a:r>
+          </a:p>
+        </p:txBody>
+      </p:sp>
+      <p:sp>
+        <p:nvSpPr>
+          <p:cNvPr id="10" name="TextBox 9">
+            <a:extLst>
+              <a:ext uri="{FF2B5EF4-FFF2-40B4-BE49-F238E27FC236}">
+                <a16:creationId xmlns:a16="http://schemas.microsoft.com/office/drawing/2014/main" id="{6DE9EA09-F463-44EE-3C3A-09ABBE695A49}"/>
+              </a:ext>
+            </a:extLst>
+          </p:cNvPr>
+          <p:cNvSpPr txBox="1"/>
+          <p:nvPr/>
+        </p:nvSpPr>
+        <p:spPr>
+          <a:xfrm>
+            <a:off x="4498513" y="3331222"/>
+            <a:ext cx="1626984" cy="646331"/>
+          </a:xfrm>
+          <a:prstGeom prst="rect">
+            <a:avLst/>
+          </a:prstGeom>
+          <a:noFill/>
+          <a:effectLst>
+            <a:outerShdw blurRad="50800" dist="38100" dir="2700000" algn="tl" rotWithShape="0">
+              <a:prstClr val="black">
+                <a:alpha val="40000"/>
+              </a:prstClr>
+            </a:outerShdw>
+          </a:effectLst>
+        </p:spPr>
+        <p:txBody>
+          <a:bodyPr wrap="none" rtlCol="0">
+            <a:spAutoFit/>
+          </a:bodyPr>
+          <a:lstStyle/>
+          <a:p>
+            <a:r>
+              <a:rPr lang="en-US" dirty="0"/>
+              <a:t>Middle Lane:</a:t>
+            </a:r>
+          </a:p>
+          <a:p>
+            <a:r>
+              <a:rPr lang="en-US" dirty="0"/>
+              <a:t>Draken’s Team</a:t>
+            </a:r>
           </a:p>
         </p:txBody>
       </p:sp>

</xml_diff>

<commit_message>
DKP: 2-column layout for Reading the Table card
</commit_message>
<xml_diff>
--- a/apps/web/public/aoo-map.pptx
+++ b/apps/web/public/aoo-map.pptx
@@ -5,12 +5,13 @@
     <p:sldMasterId id="2147483660" r:id="rId1"/>
   </p:sldMasterIdLst>
   <p:notesMasterIdLst>
-    <p:notesMasterId r:id="rId5"/>
+    <p:notesMasterId r:id="rId6"/>
   </p:notesMasterIdLst>
   <p:sldIdLst>
     <p:sldId id="256" r:id="rId2"/>
-    <p:sldId id="258" r:id="rId3"/>
-    <p:sldId id="257" r:id="rId4"/>
+    <p:sldId id="259" r:id="rId3"/>
+    <p:sldId id="258" r:id="rId4"/>
+    <p:sldId id="257" r:id="rId5"/>
   </p:sldIdLst>
   <p:sldSz cx="8961438" cy="6858000"/>
   <p:notesSz cx="6858000" cy="9144000"/>
@@ -199,7 +200,7 @@
           <a:p>
             <a:fld id="{D1A7AE60-8256-F14E-9EB4-94FADFD335EB}" type="datetimeFigureOut">
               <a:rPr lang="en-US" smtClean="0"/>
-              <a:t>2/7/26</a:t>
+              <a:t>3/21/26</a:t>
             </a:fld>
             <a:endParaRPr lang="en-US"/>
           </a:p>
@@ -494,6 +495,13 @@
           </p:nvPr>
         </p:nvSpPr>
         <p:spPr/>
+        <p:txBody>
+          <a:bodyPr/>
+          <a:lstStyle/>
+          <a:p>
+            <a:endParaRPr lang="en-US"/>
+          </a:p>
+        </p:txBody>
       </p:sp>
       <p:sp>
         <p:nvSpPr>
@@ -541,6 +549,121 @@
     <p:extLst>
       <p:ext uri="{BB962C8B-B14F-4D97-AF65-F5344CB8AC3E}">
         <p14:creationId xmlns:p14="http://schemas.microsoft.com/office/powerpoint/2010/main" val="1920205250"/>
+      </p:ext>
+    </p:extLst>
+  </p:cSld>
+  <p:clrMapOvr>
+    <a:masterClrMapping/>
+  </p:clrMapOvr>
+</p:notes>
+</file>
+
+<file path=ppt/notesSlides/notesSlide2.xml><?xml version="1.0" encoding="utf-8"?>
+<p:notes xmlns:a="http://schemas.openxmlformats.org/drawingml/2006/main" xmlns:r="http://schemas.openxmlformats.org/officeDocument/2006/relationships" xmlns:p="http://schemas.openxmlformats.org/presentationml/2006/main">
+  <p:cSld>
+    <p:spTree>
+      <p:nvGrpSpPr>
+        <p:cNvPr id="1" name="">
+          <a:extLst>
+            <a:ext uri="{FF2B5EF4-FFF2-40B4-BE49-F238E27FC236}">
+              <a16:creationId xmlns:a16="http://schemas.microsoft.com/office/drawing/2014/main" id="{73D4FA3F-7662-3796-3F80-4DB88DB2AEE6}"/>
+            </a:ext>
+          </a:extLst>
+        </p:cNvPr>
+        <p:cNvGrpSpPr/>
+        <p:nvPr/>
+      </p:nvGrpSpPr>
+      <p:grpSpPr>
+        <a:xfrm>
+          <a:off x="0" y="0"/>
+          <a:ext cx="0" cy="0"/>
+          <a:chOff x="0" y="0"/>
+          <a:chExt cx="0" cy="0"/>
+        </a:xfrm>
+      </p:grpSpPr>
+      <p:sp>
+        <p:nvSpPr>
+          <p:cNvPr id="2" name="Slide Image Placeholder 1">
+            <a:extLst>
+              <a:ext uri="{FF2B5EF4-FFF2-40B4-BE49-F238E27FC236}">
+                <a16:creationId xmlns:a16="http://schemas.microsoft.com/office/drawing/2014/main" id="{E7F1C270-8584-1244-FC36-9FF09C115176}"/>
+              </a:ext>
+            </a:extLst>
+          </p:cNvPr>
+          <p:cNvSpPr>
+            <a:spLocks noGrp="1" noRot="1" noChangeAspect="1"/>
+          </p:cNvSpPr>
+          <p:nvPr>
+            <p:ph type="sldImg"/>
+          </p:nvPr>
+        </p:nvSpPr>
+        <p:spPr/>
+        <p:txBody>
+          <a:bodyPr/>
+          <a:lstStyle/>
+          <a:p>
+            <a:endParaRPr lang="en-US"/>
+          </a:p>
+        </p:txBody>
+      </p:sp>
+      <p:sp>
+        <p:nvSpPr>
+          <p:cNvPr id="3" name="Notes Placeholder 2">
+            <a:extLst>
+              <a:ext uri="{FF2B5EF4-FFF2-40B4-BE49-F238E27FC236}">
+                <a16:creationId xmlns:a16="http://schemas.microsoft.com/office/drawing/2014/main" id="{2A964CDC-BEB7-9401-5ECC-735E094C126A}"/>
+              </a:ext>
+            </a:extLst>
+          </p:cNvPr>
+          <p:cNvSpPr>
+            <a:spLocks noGrp="1"/>
+          </p:cNvSpPr>
+          <p:nvPr>
+            <p:ph type="body" idx="1"/>
+          </p:nvPr>
+        </p:nvSpPr>
+        <p:spPr/>
+        <p:txBody>
+          <a:bodyPr/>
+          <a:lstStyle/>
+          <a:p>
+            <a:endParaRPr lang="en-US"/>
+          </a:p>
+        </p:txBody>
+      </p:sp>
+      <p:sp>
+        <p:nvSpPr>
+          <p:cNvPr id="4" name="Slide Number Placeholder 3">
+            <a:extLst>
+              <a:ext uri="{FF2B5EF4-FFF2-40B4-BE49-F238E27FC236}">
+                <a16:creationId xmlns:a16="http://schemas.microsoft.com/office/drawing/2014/main" id="{02BB2876-4A43-F31B-8258-7B9928AC3F29}"/>
+              </a:ext>
+            </a:extLst>
+          </p:cNvPr>
+          <p:cNvSpPr>
+            <a:spLocks noGrp="1"/>
+          </p:cNvSpPr>
+          <p:nvPr>
+            <p:ph type="sldNum" sz="quarter" idx="5"/>
+          </p:nvPr>
+        </p:nvSpPr>
+        <p:spPr/>
+        <p:txBody>
+          <a:bodyPr/>
+          <a:lstStyle/>
+          <a:p>
+            <a:fld id="{51AC7242-A353-7C48-AE5E-C41FCE31657F}" type="slidenum">
+              <a:rPr lang="en-US" smtClean="0"/>
+              <a:t>2</a:t>
+            </a:fld>
+            <a:endParaRPr lang="en-US"/>
+          </a:p>
+        </p:txBody>
+      </p:sp>
+    </p:spTree>
+    <p:extLst>
+      <p:ext uri="{BB962C8B-B14F-4D97-AF65-F5344CB8AC3E}">
+        <p14:creationId xmlns:p14="http://schemas.microsoft.com/office/powerpoint/2010/main" val="3542169106"/>
       </p:ext>
     </p:extLst>
   </p:cSld>
@@ -681,7 +804,7 @@
           <a:p>
             <a:fld id="{FDB6C4DE-B126-0B48-A37E-D4A228251755}" type="datetimeFigureOut">
               <a:rPr lang="en-US" smtClean="0"/>
-              <a:t>2/7/26</a:t>
+              <a:t>3/21/26</a:t>
             </a:fld>
             <a:endParaRPr lang="en-US"/>
           </a:p>
@@ -851,7 +974,7 @@
           <a:p>
             <a:fld id="{FDB6C4DE-B126-0B48-A37E-D4A228251755}" type="datetimeFigureOut">
               <a:rPr lang="en-US" smtClean="0"/>
-              <a:t>2/7/26</a:t>
+              <a:t>3/21/26</a:t>
             </a:fld>
             <a:endParaRPr lang="en-US"/>
           </a:p>
@@ -1031,7 +1154,7 @@
           <a:p>
             <a:fld id="{FDB6C4DE-B126-0B48-A37E-D4A228251755}" type="datetimeFigureOut">
               <a:rPr lang="en-US" smtClean="0"/>
-              <a:t>2/7/26</a:t>
+              <a:t>3/21/26</a:t>
             </a:fld>
             <a:endParaRPr lang="en-US"/>
           </a:p>
@@ -1201,7 +1324,7 @@
           <a:p>
             <a:fld id="{FDB6C4DE-B126-0B48-A37E-D4A228251755}" type="datetimeFigureOut">
               <a:rPr lang="en-US" smtClean="0"/>
-              <a:t>2/7/26</a:t>
+              <a:t>3/21/26</a:t>
             </a:fld>
             <a:endParaRPr lang="en-US"/>
           </a:p>
@@ -1447,7 +1570,7 @@
           <a:p>
             <a:fld id="{FDB6C4DE-B126-0B48-A37E-D4A228251755}" type="datetimeFigureOut">
               <a:rPr lang="en-US" smtClean="0"/>
-              <a:t>2/7/26</a:t>
+              <a:t>3/21/26</a:t>
             </a:fld>
             <a:endParaRPr lang="en-US"/>
           </a:p>
@@ -1679,7 +1802,7 @@
           <a:p>
             <a:fld id="{FDB6C4DE-B126-0B48-A37E-D4A228251755}" type="datetimeFigureOut">
               <a:rPr lang="en-US" smtClean="0"/>
-              <a:t>2/7/26</a:t>
+              <a:t>3/21/26</a:t>
             </a:fld>
             <a:endParaRPr lang="en-US"/>
           </a:p>
@@ -2046,7 +2169,7 @@
           <a:p>
             <a:fld id="{FDB6C4DE-B126-0B48-A37E-D4A228251755}" type="datetimeFigureOut">
               <a:rPr lang="en-US" smtClean="0"/>
-              <a:t>2/7/26</a:t>
+              <a:t>3/21/26</a:t>
             </a:fld>
             <a:endParaRPr lang="en-US"/>
           </a:p>
@@ -2164,7 +2287,7 @@
           <a:p>
             <a:fld id="{FDB6C4DE-B126-0B48-A37E-D4A228251755}" type="datetimeFigureOut">
               <a:rPr lang="en-US" smtClean="0"/>
-              <a:t>2/7/26</a:t>
+              <a:t>3/21/26</a:t>
             </a:fld>
             <a:endParaRPr lang="en-US"/>
           </a:p>
@@ -2259,7 +2382,7 @@
           <a:p>
             <a:fld id="{FDB6C4DE-B126-0B48-A37E-D4A228251755}" type="datetimeFigureOut">
               <a:rPr lang="en-US" smtClean="0"/>
-              <a:t>2/7/26</a:t>
+              <a:t>3/21/26</a:t>
             </a:fld>
             <a:endParaRPr lang="en-US"/>
           </a:p>
@@ -2536,7 +2659,7 @@
           <a:p>
             <a:fld id="{FDB6C4DE-B126-0B48-A37E-D4A228251755}" type="datetimeFigureOut">
               <a:rPr lang="en-US" smtClean="0"/>
-              <a:t>2/7/26</a:t>
+              <a:t>3/21/26</a:t>
             </a:fld>
             <a:endParaRPr lang="en-US"/>
           </a:p>
@@ -2793,7 +2916,7 @@
           <a:p>
             <a:fld id="{FDB6C4DE-B126-0B48-A37E-D4A228251755}" type="datetimeFigureOut">
               <a:rPr lang="en-US" smtClean="0"/>
-              <a:t>2/7/26</a:t>
+              <a:t>3/21/26</a:t>
             </a:fld>
             <a:endParaRPr lang="en-US"/>
           </a:p>
@@ -3006,7 +3129,7 @@
           <a:p>
             <a:fld id="{FDB6C4DE-B126-0B48-A37E-D4A228251755}" type="datetimeFigureOut">
               <a:rPr lang="en-US" smtClean="0"/>
-              <a:t>2/7/26</a:t>
+              <a:t>3/21/26</a:t>
             </a:fld>
             <a:endParaRPr lang="en-US"/>
           </a:p>
@@ -3618,7 +3741,7 @@
         <p:spPr>
           <a:xfrm>
             <a:off x="7268392" y="5347699"/>
-            <a:ext cx="934651" cy="519351"/>
+            <a:ext cx="1211548" cy="519351"/>
           </a:xfrm>
           <a:prstGeom prst="ellipse">
             <a:avLst/>
@@ -3642,7 +3765,7 @@
           <a:p>
             <a:r>
               <a:rPr lang="en-US" dirty="0"/>
-              <a:t>Start</a:t>
+              <a:t>Enemy</a:t>
             </a:r>
           </a:p>
         </p:txBody>
@@ -3662,7 +3785,7 @@
         <p:spPr>
           <a:xfrm>
             <a:off x="577331" y="496441"/>
-            <a:ext cx="1211548" cy="519351"/>
+            <a:ext cx="934651" cy="519351"/>
           </a:xfrm>
           <a:prstGeom prst="ellipse">
             <a:avLst/>
@@ -3686,7 +3809,7 @@
           <a:p>
             <a:r>
               <a:rPr lang="en-US" dirty="0"/>
-              <a:t>Enemy</a:t>
+              <a:t>Start</a:t>
             </a:r>
           </a:p>
         </p:txBody>
@@ -3700,13 +3823,15 @@
               </a:ext>
             </a:extLst>
           </p:cNvPr>
-          <p:cNvCxnSpPr/>
+          <p:cNvCxnSpPr>
+            <a:cxnSpLocks/>
+          </p:cNvCxnSpPr>
           <p:nvPr/>
         </p:nvCxnSpPr>
         <p:spPr>
-          <a:xfrm flipV="1">
-            <a:off x="7602279" y="3429000"/>
-            <a:ext cx="0" cy="1727791"/>
+          <a:xfrm>
+            <a:off x="2286000" y="758379"/>
+            <a:ext cx="2212513" cy="232571"/>
           </a:xfrm>
           <a:prstGeom prst="straightConnector1">
             <a:avLst/>
@@ -3756,9 +3881,9 @@
           <p:nvPr/>
         </p:nvCxnSpPr>
         <p:spPr>
-          <a:xfrm flipH="1" flipV="1">
-            <a:off x="4072270" y="5532365"/>
-            <a:ext cx="2955851" cy="156054"/>
+          <a:xfrm>
+            <a:off x="871870" y="1435395"/>
+            <a:ext cx="0" cy="1190847"/>
           </a:xfrm>
           <a:prstGeom prst="straightConnector1">
             <a:avLst/>
@@ -3808,9 +3933,9 @@
           <p:nvPr/>
         </p:nvCxnSpPr>
         <p:spPr>
-          <a:xfrm flipH="1" flipV="1">
-            <a:off x="6424004" y="2934586"/>
-            <a:ext cx="877383" cy="117322"/>
+          <a:xfrm>
+            <a:off x="4688958" y="1202789"/>
+            <a:ext cx="127591" cy="711071"/>
           </a:xfrm>
           <a:prstGeom prst="straightConnector1">
             <a:avLst/>
@@ -3860,9 +3985,9 @@
           <p:nvPr/>
         </p:nvCxnSpPr>
         <p:spPr>
-          <a:xfrm flipH="1" flipV="1">
-            <a:off x="7301387" y="2211572"/>
-            <a:ext cx="268902" cy="606056"/>
+          <a:xfrm>
+            <a:off x="5061098" y="1015792"/>
+            <a:ext cx="850604" cy="100627"/>
           </a:xfrm>
           <a:prstGeom prst="straightConnector1">
             <a:avLst/>
@@ -3912,9 +4037,9 @@
           <p:nvPr/>
         </p:nvCxnSpPr>
         <p:spPr>
-          <a:xfrm flipH="1" flipV="1">
-            <a:off x="2509284" y="5276956"/>
-            <a:ext cx="801321" cy="83918"/>
+          <a:xfrm>
+            <a:off x="967563" y="3051908"/>
+            <a:ext cx="0" cy="925645"/>
           </a:xfrm>
           <a:prstGeom prst="straightConnector1">
             <a:avLst/>
@@ -3964,9 +4089,9 @@
           <p:nvPr/>
         </p:nvCxnSpPr>
         <p:spPr>
-          <a:xfrm flipV="1">
-            <a:off x="3678865" y="4433777"/>
-            <a:ext cx="0" cy="723014"/>
+          <a:xfrm>
+            <a:off x="1265274" y="2817628"/>
+            <a:ext cx="1095154" cy="404037"/>
           </a:xfrm>
           <a:prstGeom prst="straightConnector1">
             <a:avLst/>
@@ -4016,9 +4141,9 @@
           <p:nvPr/>
         </p:nvCxnSpPr>
         <p:spPr>
-          <a:xfrm flipH="1" flipV="1">
-            <a:off x="5819888" y="4240838"/>
-            <a:ext cx="1208233" cy="915953"/>
+          <a:xfrm>
+            <a:off x="1969674" y="1343449"/>
+            <a:ext cx="914645" cy="617731"/>
           </a:xfrm>
           <a:prstGeom prst="straightConnector1">
             <a:avLst/>
@@ -4068,9 +4193,9 @@
           <p:nvPr/>
         </p:nvCxnSpPr>
         <p:spPr>
-          <a:xfrm flipH="1">
-            <a:off x="5550195" y="4225401"/>
-            <a:ext cx="29422" cy="633181"/>
+          <a:xfrm flipH="1" flipV="1">
+            <a:off x="1788879" y="1986171"/>
+            <a:ext cx="820285" cy="38372"/>
           </a:xfrm>
           <a:prstGeom prst="straightConnector1">
             <a:avLst/>
@@ -4120,9 +4245,9 @@
           <p:nvPr/>
         </p:nvCxnSpPr>
         <p:spPr>
-          <a:xfrm>
-            <a:off x="5768372" y="4005005"/>
-            <a:ext cx="906580" cy="0"/>
+          <a:xfrm flipV="1">
+            <a:off x="3027453" y="1259384"/>
+            <a:ext cx="37661" cy="654476"/>
           </a:xfrm>
           <a:prstGeom prst="straightConnector1">
             <a:avLst/>
@@ -4172,7 +4297,935 @@
         <p:spPr>
           <a:xfrm>
             <a:off x="6621188" y="556458"/>
-            <a:ext cx="1665328" cy="646331"/>
+            <a:ext cx="1320618" cy="646331"/>
+          </a:xfrm>
+          <a:prstGeom prst="rect">
+            <a:avLst/>
+          </a:prstGeom>
+          <a:noFill/>
+          <a:effectLst>
+            <a:outerShdw blurRad="50800" dist="38100" dir="2700000" algn="tl" rotWithShape="0">
+              <a:prstClr val="black">
+                <a:alpha val="40000"/>
+              </a:prstClr>
+            </a:outerShdw>
+          </a:effectLst>
+        </p:spPr>
+        <p:txBody>
+          <a:bodyPr wrap="none" rtlCol="0">
+            <a:spAutoFit/>
+          </a:bodyPr>
+          <a:lstStyle/>
+          <a:p>
+            <a:r>
+              <a:rPr lang="en-US" dirty="0"/>
+              <a:t>Top Lane:</a:t>
+            </a:r>
+          </a:p>
+          <a:p>
+            <a:r>
+              <a:rPr lang="en-US" dirty="0"/>
+              <a:t>Fluffy Team</a:t>
+            </a:r>
+          </a:p>
+        </p:txBody>
+      </p:sp>
+      <p:sp>
+        <p:nvSpPr>
+          <p:cNvPr id="10" name="TextBox 9">
+            <a:extLst>
+              <a:ext uri="{FF2B5EF4-FFF2-40B4-BE49-F238E27FC236}">
+                <a16:creationId xmlns:a16="http://schemas.microsoft.com/office/drawing/2014/main" id="{6DE9EA09-F463-44EE-3C3A-09ABBE695A49}"/>
+              </a:ext>
+            </a:extLst>
+          </p:cNvPr>
+          <p:cNvSpPr txBox="1"/>
+          <p:nvPr/>
+        </p:nvSpPr>
+        <p:spPr>
+          <a:xfrm>
+            <a:off x="2427259" y="2266359"/>
+            <a:ext cx="2321085" cy="646331"/>
+          </a:xfrm>
+          <a:prstGeom prst="rect">
+            <a:avLst/>
+          </a:prstGeom>
+          <a:noFill/>
+          <a:effectLst>
+            <a:outerShdw blurRad="50800" dist="38100" dir="2700000" algn="tl" rotWithShape="0">
+              <a:prstClr val="black">
+                <a:alpha val="40000"/>
+              </a:prstClr>
+            </a:outerShdw>
+          </a:effectLst>
+        </p:spPr>
+        <p:txBody>
+          <a:bodyPr wrap="none" rtlCol="0">
+            <a:spAutoFit/>
+          </a:bodyPr>
+          <a:lstStyle/>
+          <a:p>
+            <a:r>
+              <a:rPr lang="en-US" dirty="0"/>
+              <a:t>Middle Lane:</a:t>
+            </a:r>
+          </a:p>
+          <a:p>
+            <a:r>
+              <a:rPr lang="en-US" dirty="0"/>
+              <a:t>Michael, Fluffy Prince</a:t>
+            </a:r>
+          </a:p>
+        </p:txBody>
+      </p:sp>
+      <p:sp>
+        <p:nvSpPr>
+          <p:cNvPr id="38" name="TextBox 37">
+            <a:extLst>
+              <a:ext uri="{FF2B5EF4-FFF2-40B4-BE49-F238E27FC236}">
+                <a16:creationId xmlns:a16="http://schemas.microsoft.com/office/drawing/2014/main" id="{581A821C-57B8-875F-94AA-5C122818C1CE}"/>
+              </a:ext>
+            </a:extLst>
+          </p:cNvPr>
+          <p:cNvSpPr txBox="1"/>
+          <p:nvPr/>
+        </p:nvSpPr>
+        <p:spPr>
+          <a:xfrm>
+            <a:off x="97612" y="4360737"/>
+            <a:ext cx="1614866" cy="646331"/>
+          </a:xfrm>
+          <a:prstGeom prst="rect">
+            <a:avLst/>
+          </a:prstGeom>
+          <a:noFill/>
+          <a:effectLst>
+            <a:outerShdw blurRad="50800" dist="38100" dir="2700000" algn="tl" rotWithShape="0">
+              <a:prstClr val="black">
+                <a:alpha val="40000"/>
+              </a:prstClr>
+            </a:outerShdw>
+          </a:effectLst>
+        </p:spPr>
+        <p:txBody>
+          <a:bodyPr wrap="none" rtlCol="0">
+            <a:spAutoFit/>
+          </a:bodyPr>
+          <a:lstStyle/>
+          <a:p>
+            <a:r>
+              <a:rPr lang="en-US" dirty="0"/>
+              <a:t>Bottom Lane:</a:t>
+            </a:r>
+          </a:p>
+          <a:p>
+            <a:r>
+              <a:rPr lang="en-US" dirty="0"/>
+              <a:t>Suntzu’s Team</a:t>
+            </a:r>
+          </a:p>
+        </p:txBody>
+      </p:sp>
+    </p:spTree>
+    <p:extLst>
+      <p:ext uri="{BB962C8B-B14F-4D97-AF65-F5344CB8AC3E}">
+        <p14:creationId xmlns:p14="http://schemas.microsoft.com/office/powerpoint/2010/main" val="2075628722"/>
+      </p:ext>
+    </p:extLst>
+  </p:cSld>
+  <p:clrMapOvr>
+    <a:masterClrMapping/>
+  </p:clrMapOvr>
+</p:sld>
+</file>
+
+<file path=ppt/slides/slide2.xml><?xml version="1.0" encoding="utf-8"?>
+<p:sld xmlns:a="http://schemas.openxmlformats.org/drawingml/2006/main" xmlns:r="http://schemas.openxmlformats.org/officeDocument/2006/relationships" xmlns:p="http://schemas.openxmlformats.org/presentationml/2006/main">
+  <p:cSld>
+    <p:spTree>
+      <p:nvGrpSpPr>
+        <p:cNvPr id="1" name="">
+          <a:extLst>
+            <a:ext uri="{FF2B5EF4-FFF2-40B4-BE49-F238E27FC236}">
+              <a16:creationId xmlns:a16="http://schemas.microsoft.com/office/drawing/2014/main" id="{49FB230A-A5F2-394D-FB2A-D1919637C936}"/>
+            </a:ext>
+          </a:extLst>
+        </p:cNvPr>
+        <p:cNvGrpSpPr/>
+        <p:nvPr/>
+      </p:nvGrpSpPr>
+      <p:grpSpPr>
+        <a:xfrm>
+          <a:off x="0" y="0"/>
+          <a:ext cx="0" cy="0"/>
+          <a:chOff x="0" y="0"/>
+          <a:chExt cx="0" cy="0"/>
+        </a:xfrm>
+      </p:grpSpPr>
+      <p:pic>
+        <p:nvPicPr>
+          <p:cNvPr id="6" name="Picture 5" descr="A game of a board game&#10;&#10;AI-generated content may be incorrect.">
+            <a:extLst>
+              <a:ext uri="{FF2B5EF4-FFF2-40B4-BE49-F238E27FC236}">
+                <a16:creationId xmlns:a16="http://schemas.microsoft.com/office/drawing/2014/main" id="{779DA9E8-2B60-7E04-FDC2-F2E800CD167E}"/>
+              </a:ext>
+            </a:extLst>
+          </p:cNvPr>
+          <p:cNvPicPr>
+            <a:picLocks noChangeAspect="1"/>
+          </p:cNvPicPr>
+          <p:nvPr/>
+        </p:nvPicPr>
+        <p:blipFill>
+          <a:blip r:embed="rId3"/>
+          <a:stretch>
+            <a:fillRect/>
+          </a:stretch>
+        </p:blipFill>
+        <p:spPr>
+          <a:xfrm>
+            <a:off x="1" y="0"/>
+            <a:ext cx="8964707" cy="6858000"/>
+          </a:xfrm>
+          <a:prstGeom prst="rect">
+            <a:avLst/>
+          </a:prstGeom>
+        </p:spPr>
+      </p:pic>
+      <p:sp>
+        <p:nvSpPr>
+          <p:cNvPr id="7" name="Rectangle 6">
+            <a:extLst>
+              <a:ext uri="{FF2B5EF4-FFF2-40B4-BE49-F238E27FC236}">
+                <a16:creationId xmlns:a16="http://schemas.microsoft.com/office/drawing/2014/main" id="{07B4B7B5-9F9D-520B-6452-A2AC69F7D3AA}"/>
+              </a:ext>
+            </a:extLst>
+          </p:cNvPr>
+          <p:cNvSpPr/>
+          <p:nvPr/>
+        </p:nvSpPr>
+        <p:spPr>
+          <a:xfrm rot="1979634">
+            <a:off x="-131765" y="3372644"/>
+            <a:ext cx="6582822" cy="2574389"/>
+          </a:xfrm>
+          <a:prstGeom prst="rect">
+            <a:avLst/>
+          </a:prstGeom>
+          <a:solidFill>
+            <a:schemeClr val="accent5">
+              <a:alpha val="20000"/>
+            </a:schemeClr>
+          </a:solidFill>
+          <a:ln>
+            <a:noFill/>
+          </a:ln>
+        </p:spPr>
+        <p:style>
+          <a:lnRef idx="2">
+            <a:schemeClr val="accent1">
+              <a:shade val="15000"/>
+            </a:schemeClr>
+          </a:lnRef>
+          <a:fillRef idx="1">
+            <a:schemeClr val="accent1"/>
+          </a:fillRef>
+          <a:effectRef idx="0">
+            <a:schemeClr val="accent1"/>
+          </a:effectRef>
+          <a:fontRef idx="minor">
+            <a:schemeClr val="lt1"/>
+          </a:fontRef>
+        </p:style>
+        <p:txBody>
+          <a:bodyPr rtlCol="0" anchor="ctr"/>
+          <a:lstStyle/>
+          <a:p>
+            <a:pPr algn="ctr"/>
+            <a:endParaRPr lang="en-US"/>
+          </a:p>
+        </p:txBody>
+      </p:sp>
+      <p:sp>
+        <p:nvSpPr>
+          <p:cNvPr id="8" name="Rectangle 7">
+            <a:extLst>
+              <a:ext uri="{FF2B5EF4-FFF2-40B4-BE49-F238E27FC236}">
+                <a16:creationId xmlns:a16="http://schemas.microsoft.com/office/drawing/2014/main" id="{72A13005-6E49-68D8-F960-B17AAD70997B}"/>
+              </a:ext>
+            </a:extLst>
+          </p:cNvPr>
+          <p:cNvSpPr/>
+          <p:nvPr/>
+        </p:nvSpPr>
+        <p:spPr>
+          <a:xfrm rot="1979634">
+            <a:off x="1896508" y="385411"/>
+            <a:ext cx="6558877" cy="2337741"/>
+          </a:xfrm>
+          <a:prstGeom prst="rect">
+            <a:avLst/>
+          </a:prstGeom>
+          <a:solidFill>
+            <a:schemeClr val="accent4">
+              <a:alpha val="20000"/>
+            </a:schemeClr>
+          </a:solidFill>
+          <a:ln>
+            <a:noFill/>
+          </a:ln>
+        </p:spPr>
+        <p:style>
+          <a:lnRef idx="2">
+            <a:schemeClr val="accent1">
+              <a:shade val="15000"/>
+            </a:schemeClr>
+          </a:lnRef>
+          <a:fillRef idx="1">
+            <a:schemeClr val="accent1"/>
+          </a:fillRef>
+          <a:effectRef idx="0">
+            <a:schemeClr val="accent1"/>
+          </a:effectRef>
+          <a:fontRef idx="minor">
+            <a:schemeClr val="lt1"/>
+          </a:fontRef>
+        </p:style>
+        <p:txBody>
+          <a:bodyPr rtlCol="0" anchor="ctr"/>
+          <a:lstStyle/>
+          <a:p>
+            <a:pPr algn="ctr"/>
+            <a:endParaRPr lang="en-US"/>
+          </a:p>
+        </p:txBody>
+      </p:sp>
+      <p:sp>
+        <p:nvSpPr>
+          <p:cNvPr id="9" name="Rectangle 8">
+            <a:extLst>
+              <a:ext uri="{FF2B5EF4-FFF2-40B4-BE49-F238E27FC236}">
+                <a16:creationId xmlns:a16="http://schemas.microsoft.com/office/drawing/2014/main" id="{3AB006C9-81E4-C7DA-A5C0-6B98B1477560}"/>
+              </a:ext>
+            </a:extLst>
+          </p:cNvPr>
+          <p:cNvSpPr/>
+          <p:nvPr/>
+        </p:nvSpPr>
+        <p:spPr>
+          <a:xfrm rot="1979634">
+            <a:off x="901795" y="2449619"/>
+            <a:ext cx="6568256" cy="1204578"/>
+          </a:xfrm>
+          <a:prstGeom prst="rect">
+            <a:avLst/>
+          </a:prstGeom>
+          <a:solidFill>
+            <a:schemeClr val="accent2">
+              <a:alpha val="20000"/>
+            </a:schemeClr>
+          </a:solidFill>
+          <a:ln>
+            <a:noFill/>
+          </a:ln>
+        </p:spPr>
+        <p:style>
+          <a:lnRef idx="2">
+            <a:schemeClr val="accent1">
+              <a:shade val="15000"/>
+            </a:schemeClr>
+          </a:lnRef>
+          <a:fillRef idx="1">
+            <a:schemeClr val="accent1"/>
+          </a:fillRef>
+          <a:effectRef idx="0">
+            <a:schemeClr val="accent1"/>
+          </a:effectRef>
+          <a:fontRef idx="minor">
+            <a:schemeClr val="lt1"/>
+          </a:fontRef>
+        </p:style>
+        <p:txBody>
+          <a:bodyPr rtlCol="0" anchor="ctr"/>
+          <a:lstStyle/>
+          <a:p>
+            <a:pPr algn="ctr"/>
+            <a:endParaRPr lang="en-US"/>
+          </a:p>
+        </p:txBody>
+      </p:sp>
+      <p:sp>
+        <p:nvSpPr>
+          <p:cNvPr id="2" name="TextBox 1">
+            <a:extLst>
+              <a:ext uri="{FF2B5EF4-FFF2-40B4-BE49-F238E27FC236}">
+                <a16:creationId xmlns:a16="http://schemas.microsoft.com/office/drawing/2014/main" id="{45AAD8EC-F964-AFEF-188B-D940DEDB5F3F}"/>
+              </a:ext>
+            </a:extLst>
+          </p:cNvPr>
+          <p:cNvSpPr txBox="1"/>
+          <p:nvPr/>
+        </p:nvSpPr>
+        <p:spPr>
+          <a:xfrm>
+            <a:off x="7268392" y="5347699"/>
+            <a:ext cx="934651" cy="519351"/>
+          </a:xfrm>
+          <a:prstGeom prst="ellipse">
+            <a:avLst/>
+          </a:prstGeom>
+          <a:solidFill>
+            <a:srgbClr val="FF0000"/>
+          </a:solidFill>
+          <a:effectLst>
+            <a:outerShdw blurRad="50800" dist="38100" dir="2700000" algn="tl" rotWithShape="0">
+              <a:prstClr val="black">
+                <a:alpha val="40000"/>
+              </a:prstClr>
+            </a:outerShdw>
+          </a:effectLst>
+        </p:spPr>
+        <p:txBody>
+          <a:bodyPr wrap="none" rtlCol="0">
+            <a:spAutoFit/>
+          </a:bodyPr>
+          <a:lstStyle/>
+          <a:p>
+            <a:r>
+              <a:rPr lang="en-US" dirty="0"/>
+              <a:t>Start</a:t>
+            </a:r>
+          </a:p>
+        </p:txBody>
+      </p:sp>
+      <p:sp>
+        <p:nvSpPr>
+          <p:cNvPr id="3" name="TextBox 2">
+            <a:extLst>
+              <a:ext uri="{FF2B5EF4-FFF2-40B4-BE49-F238E27FC236}">
+                <a16:creationId xmlns:a16="http://schemas.microsoft.com/office/drawing/2014/main" id="{6378D4DC-0615-4F1E-A0F5-890C251BC208}"/>
+              </a:ext>
+            </a:extLst>
+          </p:cNvPr>
+          <p:cNvSpPr txBox="1"/>
+          <p:nvPr/>
+        </p:nvSpPr>
+        <p:spPr>
+          <a:xfrm>
+            <a:off x="577331" y="496441"/>
+            <a:ext cx="1211548" cy="519351"/>
+          </a:xfrm>
+          <a:prstGeom prst="ellipse">
+            <a:avLst/>
+          </a:prstGeom>
+          <a:solidFill>
+            <a:schemeClr val="accent4"/>
+          </a:solidFill>
+          <a:effectLst>
+            <a:outerShdw blurRad="50800" dist="38100" dir="2700000" algn="tl" rotWithShape="0">
+              <a:prstClr val="black">
+                <a:alpha val="40000"/>
+              </a:prstClr>
+            </a:outerShdw>
+          </a:effectLst>
+        </p:spPr>
+        <p:txBody>
+          <a:bodyPr wrap="none" rtlCol="0">
+            <a:spAutoFit/>
+          </a:bodyPr>
+          <a:lstStyle/>
+          <a:p>
+            <a:r>
+              <a:rPr lang="en-US" dirty="0"/>
+              <a:t>Enemy</a:t>
+            </a:r>
+          </a:p>
+        </p:txBody>
+      </p:sp>
+      <p:cxnSp>
+        <p:nvCxnSpPr>
+          <p:cNvPr id="5" name="Straight Arrow Connector 4">
+            <a:extLst>
+              <a:ext uri="{FF2B5EF4-FFF2-40B4-BE49-F238E27FC236}">
+                <a16:creationId xmlns:a16="http://schemas.microsoft.com/office/drawing/2014/main" id="{CF86B7D1-5562-F10E-0073-F7844E335062}"/>
+              </a:ext>
+            </a:extLst>
+          </p:cNvPr>
+          <p:cNvCxnSpPr>
+            <a:cxnSpLocks/>
+          </p:cNvCxnSpPr>
+          <p:nvPr/>
+        </p:nvCxnSpPr>
+        <p:spPr>
+          <a:xfrm flipV="1">
+            <a:off x="7588750" y="3331222"/>
+            <a:ext cx="68855" cy="1341741"/>
+          </a:xfrm>
+          <a:prstGeom prst="straightConnector1">
+            <a:avLst/>
+          </a:prstGeom>
+          <a:ln w="47625">
+            <a:solidFill>
+              <a:schemeClr val="accent4"/>
+            </a:solidFill>
+            <a:headEnd w="lg" len="lg"/>
+            <a:tailEnd type="arrow"/>
+          </a:ln>
+          <a:effectLst>
+            <a:outerShdw blurRad="50800" dist="38100" dir="2700000" algn="tl" rotWithShape="0">
+              <a:prstClr val="black">
+                <a:alpha val="40000"/>
+              </a:prstClr>
+            </a:outerShdw>
+          </a:effectLst>
+        </p:spPr>
+        <p:style>
+          <a:lnRef idx="2">
+            <a:schemeClr val="accent1"/>
+          </a:lnRef>
+          <a:fillRef idx="0">
+            <a:schemeClr val="accent1"/>
+          </a:fillRef>
+          <a:effectRef idx="1">
+            <a:schemeClr val="accent1"/>
+          </a:effectRef>
+          <a:fontRef idx="minor">
+            <a:schemeClr val="tx1"/>
+          </a:fontRef>
+        </p:style>
+      </p:cxnSp>
+      <p:cxnSp>
+        <p:nvCxnSpPr>
+          <p:cNvPr id="11" name="Straight Arrow Connector 10">
+            <a:extLst>
+              <a:ext uri="{FF2B5EF4-FFF2-40B4-BE49-F238E27FC236}">
+                <a16:creationId xmlns:a16="http://schemas.microsoft.com/office/drawing/2014/main" id="{9D093B06-7C33-D727-2E79-5F1B0653F530}"/>
+              </a:ext>
+            </a:extLst>
+          </p:cNvPr>
+          <p:cNvCxnSpPr>
+            <a:cxnSpLocks/>
+          </p:cNvCxnSpPr>
+          <p:nvPr/>
+        </p:nvCxnSpPr>
+        <p:spPr>
+          <a:xfrm flipH="1" flipV="1">
+            <a:off x="3939753" y="5520343"/>
+            <a:ext cx="2408940" cy="199973"/>
+          </a:xfrm>
+          <a:prstGeom prst="straightConnector1">
+            <a:avLst/>
+          </a:prstGeom>
+          <a:ln w="47625">
+            <a:solidFill>
+              <a:schemeClr val="accent5"/>
+            </a:solidFill>
+            <a:headEnd w="lg" len="lg"/>
+            <a:tailEnd type="arrow"/>
+          </a:ln>
+          <a:effectLst>
+            <a:outerShdw blurRad="50800" dist="38100" dir="2700000" algn="tl" rotWithShape="0">
+              <a:prstClr val="black">
+                <a:alpha val="40000"/>
+              </a:prstClr>
+            </a:outerShdw>
+          </a:effectLst>
+        </p:spPr>
+        <p:style>
+          <a:lnRef idx="2">
+            <a:schemeClr val="accent1"/>
+          </a:lnRef>
+          <a:fillRef idx="0">
+            <a:schemeClr val="accent1"/>
+          </a:fillRef>
+          <a:effectRef idx="1">
+            <a:schemeClr val="accent1"/>
+          </a:effectRef>
+          <a:fontRef idx="minor">
+            <a:schemeClr val="tx1"/>
+          </a:fontRef>
+        </p:style>
+      </p:cxnSp>
+      <p:cxnSp>
+        <p:nvCxnSpPr>
+          <p:cNvPr id="12" name="Straight Arrow Connector 11">
+            <a:extLst>
+              <a:ext uri="{FF2B5EF4-FFF2-40B4-BE49-F238E27FC236}">
+                <a16:creationId xmlns:a16="http://schemas.microsoft.com/office/drawing/2014/main" id="{6F24A2AB-8A8A-D996-9E34-63348BE35EF9}"/>
+              </a:ext>
+            </a:extLst>
+          </p:cNvPr>
+          <p:cNvCxnSpPr>
+            <a:cxnSpLocks/>
+          </p:cNvCxnSpPr>
+          <p:nvPr/>
+        </p:nvCxnSpPr>
+        <p:spPr>
+          <a:xfrm flipH="1" flipV="1">
+            <a:off x="6348693" y="2992862"/>
+            <a:ext cx="912811" cy="132001"/>
+          </a:xfrm>
+          <a:prstGeom prst="straightConnector1">
+            <a:avLst/>
+          </a:prstGeom>
+          <a:ln w="47625">
+            <a:solidFill>
+              <a:schemeClr val="accent4"/>
+            </a:solidFill>
+            <a:headEnd w="lg" len="lg"/>
+            <a:tailEnd type="arrow"/>
+          </a:ln>
+          <a:effectLst>
+            <a:outerShdw blurRad="50800" dist="38100" dir="2700000" algn="tl" rotWithShape="0">
+              <a:prstClr val="black">
+                <a:alpha val="40000"/>
+              </a:prstClr>
+            </a:outerShdw>
+          </a:effectLst>
+        </p:spPr>
+        <p:style>
+          <a:lnRef idx="2">
+            <a:schemeClr val="accent1"/>
+          </a:lnRef>
+          <a:fillRef idx="0">
+            <a:schemeClr val="accent1"/>
+          </a:fillRef>
+          <a:effectRef idx="1">
+            <a:schemeClr val="accent1"/>
+          </a:effectRef>
+          <a:fontRef idx="minor">
+            <a:schemeClr val="tx1"/>
+          </a:fontRef>
+        </p:style>
+      </p:cxnSp>
+      <p:cxnSp>
+        <p:nvCxnSpPr>
+          <p:cNvPr id="15" name="Straight Arrow Connector 14">
+            <a:extLst>
+              <a:ext uri="{FF2B5EF4-FFF2-40B4-BE49-F238E27FC236}">
+                <a16:creationId xmlns:a16="http://schemas.microsoft.com/office/drawing/2014/main" id="{213F07FD-B232-A405-4F78-2FBC9E1644BD}"/>
+              </a:ext>
+            </a:extLst>
+          </p:cNvPr>
+          <p:cNvCxnSpPr>
+            <a:cxnSpLocks/>
+          </p:cNvCxnSpPr>
+          <p:nvPr/>
+        </p:nvCxnSpPr>
+        <p:spPr>
+          <a:xfrm flipH="1" flipV="1">
+            <a:off x="7341418" y="2074632"/>
+            <a:ext cx="228871" cy="657971"/>
+          </a:xfrm>
+          <a:prstGeom prst="straightConnector1">
+            <a:avLst/>
+          </a:prstGeom>
+          <a:ln w="47625">
+            <a:solidFill>
+              <a:schemeClr val="accent4"/>
+            </a:solidFill>
+            <a:headEnd w="lg" len="lg"/>
+            <a:tailEnd type="arrow"/>
+          </a:ln>
+          <a:effectLst>
+            <a:outerShdw blurRad="50800" dist="38100" dir="2700000" algn="tl" rotWithShape="0">
+              <a:prstClr val="black">
+                <a:alpha val="40000"/>
+              </a:prstClr>
+            </a:outerShdw>
+          </a:effectLst>
+        </p:spPr>
+        <p:style>
+          <a:lnRef idx="2">
+            <a:schemeClr val="accent1"/>
+          </a:lnRef>
+          <a:fillRef idx="0">
+            <a:schemeClr val="accent1"/>
+          </a:fillRef>
+          <a:effectRef idx="1">
+            <a:schemeClr val="accent1"/>
+          </a:effectRef>
+          <a:fontRef idx="minor">
+            <a:schemeClr val="tx1"/>
+          </a:fontRef>
+        </p:style>
+      </p:cxnSp>
+      <p:cxnSp>
+        <p:nvCxnSpPr>
+          <p:cNvPr id="19" name="Straight Arrow Connector 18">
+            <a:extLst>
+              <a:ext uri="{FF2B5EF4-FFF2-40B4-BE49-F238E27FC236}">
+                <a16:creationId xmlns:a16="http://schemas.microsoft.com/office/drawing/2014/main" id="{9337CDAD-2E04-17EF-F1A4-A04B0DB13FB8}"/>
+              </a:ext>
+            </a:extLst>
+          </p:cNvPr>
+          <p:cNvCxnSpPr>
+            <a:cxnSpLocks/>
+          </p:cNvCxnSpPr>
+          <p:nvPr/>
+        </p:nvCxnSpPr>
+        <p:spPr>
+          <a:xfrm flipH="1" flipV="1">
+            <a:off x="2515492" y="5345437"/>
+            <a:ext cx="844396" cy="77168"/>
+          </a:xfrm>
+          <a:prstGeom prst="straightConnector1">
+            <a:avLst/>
+          </a:prstGeom>
+          <a:ln w="47625">
+            <a:solidFill>
+              <a:schemeClr val="accent5"/>
+            </a:solidFill>
+            <a:headEnd w="lg" len="lg"/>
+            <a:tailEnd type="arrow"/>
+          </a:ln>
+          <a:effectLst>
+            <a:outerShdw blurRad="50800" dist="38100" dir="2700000" algn="tl" rotWithShape="0">
+              <a:prstClr val="black">
+                <a:alpha val="40000"/>
+              </a:prstClr>
+            </a:outerShdw>
+          </a:effectLst>
+        </p:spPr>
+        <p:style>
+          <a:lnRef idx="2">
+            <a:schemeClr val="accent1"/>
+          </a:lnRef>
+          <a:fillRef idx="0">
+            <a:schemeClr val="accent1"/>
+          </a:fillRef>
+          <a:effectRef idx="1">
+            <a:schemeClr val="accent1"/>
+          </a:effectRef>
+          <a:fontRef idx="minor">
+            <a:schemeClr val="tx1"/>
+          </a:fontRef>
+        </p:style>
+      </p:cxnSp>
+      <p:cxnSp>
+        <p:nvCxnSpPr>
+          <p:cNvPr id="22" name="Straight Arrow Connector 21">
+            <a:extLst>
+              <a:ext uri="{FF2B5EF4-FFF2-40B4-BE49-F238E27FC236}">
+                <a16:creationId xmlns:a16="http://schemas.microsoft.com/office/drawing/2014/main" id="{1C8E7E57-18D4-F15F-42C6-62303B07FD4B}"/>
+              </a:ext>
+            </a:extLst>
+          </p:cNvPr>
+          <p:cNvCxnSpPr>
+            <a:cxnSpLocks/>
+          </p:cNvCxnSpPr>
+          <p:nvPr/>
+        </p:nvCxnSpPr>
+        <p:spPr>
+          <a:xfrm flipH="1" flipV="1">
+            <a:off x="3717360" y="4320464"/>
+            <a:ext cx="222393" cy="1024973"/>
+          </a:xfrm>
+          <a:prstGeom prst="straightConnector1">
+            <a:avLst/>
+          </a:prstGeom>
+          <a:ln w="47625">
+            <a:solidFill>
+              <a:schemeClr val="accent5"/>
+            </a:solidFill>
+            <a:headEnd w="lg" len="lg"/>
+            <a:tailEnd type="arrow"/>
+          </a:ln>
+          <a:effectLst>
+            <a:outerShdw blurRad="50800" dist="38100" dir="2700000" algn="tl" rotWithShape="0">
+              <a:prstClr val="black">
+                <a:alpha val="40000"/>
+              </a:prstClr>
+            </a:outerShdw>
+          </a:effectLst>
+        </p:spPr>
+        <p:style>
+          <a:lnRef idx="2">
+            <a:schemeClr val="accent1"/>
+          </a:lnRef>
+          <a:fillRef idx="0">
+            <a:schemeClr val="accent1"/>
+          </a:fillRef>
+          <a:effectRef idx="1">
+            <a:schemeClr val="accent1"/>
+          </a:effectRef>
+          <a:fontRef idx="minor">
+            <a:schemeClr val="tx1"/>
+          </a:fontRef>
+        </p:style>
+      </p:cxnSp>
+      <p:cxnSp>
+        <p:nvCxnSpPr>
+          <p:cNvPr id="25" name="Straight Arrow Connector 24">
+            <a:extLst>
+              <a:ext uri="{FF2B5EF4-FFF2-40B4-BE49-F238E27FC236}">
+                <a16:creationId xmlns:a16="http://schemas.microsoft.com/office/drawing/2014/main" id="{A6879094-ECA0-BA38-0D54-B4688FE025BA}"/>
+              </a:ext>
+            </a:extLst>
+          </p:cNvPr>
+          <p:cNvCxnSpPr>
+            <a:cxnSpLocks/>
+          </p:cNvCxnSpPr>
+          <p:nvPr/>
+        </p:nvCxnSpPr>
+        <p:spPr>
+          <a:xfrm flipH="1" flipV="1">
+            <a:off x="5730536" y="4183912"/>
+            <a:ext cx="1004604" cy="665062"/>
+          </a:xfrm>
+          <a:prstGeom prst="straightConnector1">
+            <a:avLst/>
+          </a:prstGeom>
+          <a:ln w="47625">
+            <a:solidFill>
+              <a:schemeClr val="accent2"/>
+            </a:solidFill>
+            <a:headEnd w="lg" len="lg"/>
+            <a:tailEnd type="arrow"/>
+          </a:ln>
+          <a:effectLst>
+            <a:outerShdw blurRad="50800" dist="38100" dir="2700000" algn="tl" rotWithShape="0">
+              <a:prstClr val="black">
+                <a:alpha val="40000"/>
+              </a:prstClr>
+            </a:outerShdw>
+          </a:effectLst>
+        </p:spPr>
+        <p:style>
+          <a:lnRef idx="2">
+            <a:schemeClr val="accent1"/>
+          </a:lnRef>
+          <a:fillRef idx="0">
+            <a:schemeClr val="accent1"/>
+          </a:fillRef>
+          <a:effectRef idx="1">
+            <a:schemeClr val="accent1"/>
+          </a:effectRef>
+          <a:fontRef idx="minor">
+            <a:schemeClr val="tx1"/>
+          </a:fontRef>
+        </p:style>
+      </p:cxnSp>
+      <p:cxnSp>
+        <p:nvCxnSpPr>
+          <p:cNvPr id="28" name="Straight Arrow Connector 27">
+            <a:extLst>
+              <a:ext uri="{FF2B5EF4-FFF2-40B4-BE49-F238E27FC236}">
+                <a16:creationId xmlns:a16="http://schemas.microsoft.com/office/drawing/2014/main" id="{69748AFE-1453-F8BF-1BF0-FF0E4F44A76F}"/>
+              </a:ext>
+            </a:extLst>
+          </p:cNvPr>
+          <p:cNvCxnSpPr>
+            <a:cxnSpLocks/>
+          </p:cNvCxnSpPr>
+          <p:nvPr/>
+        </p:nvCxnSpPr>
+        <p:spPr>
+          <a:xfrm>
+            <a:off x="5826642" y="3977553"/>
+            <a:ext cx="929801" cy="7663"/>
+          </a:xfrm>
+          <a:prstGeom prst="straightConnector1">
+            <a:avLst/>
+          </a:prstGeom>
+          <a:ln w="47625">
+            <a:solidFill>
+              <a:schemeClr val="accent2"/>
+            </a:solidFill>
+            <a:headEnd w="lg" len="lg"/>
+            <a:tailEnd type="arrow"/>
+          </a:ln>
+          <a:effectLst>
+            <a:outerShdw blurRad="50800" dist="38100" dir="2700000" algn="tl" rotWithShape="0">
+              <a:prstClr val="black">
+                <a:alpha val="40000"/>
+              </a:prstClr>
+            </a:outerShdw>
+          </a:effectLst>
+        </p:spPr>
+        <p:style>
+          <a:lnRef idx="2">
+            <a:schemeClr val="accent1"/>
+          </a:lnRef>
+          <a:fillRef idx="0">
+            <a:schemeClr val="accent1"/>
+          </a:fillRef>
+          <a:effectRef idx="1">
+            <a:schemeClr val="accent1"/>
+          </a:effectRef>
+          <a:fontRef idx="minor">
+            <a:schemeClr val="tx1"/>
+          </a:fontRef>
+        </p:style>
+      </p:cxnSp>
+      <p:cxnSp>
+        <p:nvCxnSpPr>
+          <p:cNvPr id="32" name="Straight Arrow Connector 31">
+            <a:extLst>
+              <a:ext uri="{FF2B5EF4-FFF2-40B4-BE49-F238E27FC236}">
+                <a16:creationId xmlns:a16="http://schemas.microsoft.com/office/drawing/2014/main" id="{C4310B41-CEB8-8244-B20B-769D24D50E75}"/>
+              </a:ext>
+            </a:extLst>
+          </p:cNvPr>
+          <p:cNvCxnSpPr>
+            <a:cxnSpLocks/>
+          </p:cNvCxnSpPr>
+          <p:nvPr/>
+        </p:nvCxnSpPr>
+        <p:spPr>
+          <a:xfrm>
+            <a:off x="5494205" y="4169206"/>
+            <a:ext cx="50545" cy="749877"/>
+          </a:xfrm>
+          <a:prstGeom prst="straightConnector1">
+            <a:avLst/>
+          </a:prstGeom>
+          <a:ln w="47625">
+            <a:solidFill>
+              <a:schemeClr val="accent2"/>
+            </a:solidFill>
+            <a:headEnd w="lg" len="lg"/>
+            <a:tailEnd type="arrow"/>
+          </a:ln>
+          <a:effectLst>
+            <a:outerShdw blurRad="50800" dist="38100" dir="2700000" algn="tl" rotWithShape="0">
+              <a:prstClr val="black">
+                <a:alpha val="40000"/>
+              </a:prstClr>
+            </a:outerShdw>
+          </a:effectLst>
+        </p:spPr>
+        <p:style>
+          <a:lnRef idx="2">
+            <a:schemeClr val="accent1"/>
+          </a:lnRef>
+          <a:fillRef idx="0">
+            <a:schemeClr val="accent1"/>
+          </a:fillRef>
+          <a:effectRef idx="1">
+            <a:schemeClr val="accent1"/>
+          </a:effectRef>
+          <a:fontRef idx="minor">
+            <a:schemeClr val="tx1"/>
+          </a:fontRef>
+        </p:style>
+      </p:cxnSp>
+      <p:sp>
+        <p:nvSpPr>
+          <p:cNvPr id="35" name="TextBox 34">
+            <a:extLst>
+              <a:ext uri="{FF2B5EF4-FFF2-40B4-BE49-F238E27FC236}">
+                <a16:creationId xmlns:a16="http://schemas.microsoft.com/office/drawing/2014/main" id="{DD910816-66DE-FA0E-2303-4E0A2ECFA61A}"/>
+              </a:ext>
+            </a:extLst>
+          </p:cNvPr>
+          <p:cNvSpPr txBox="1"/>
+          <p:nvPr/>
+        </p:nvSpPr>
+        <p:spPr>
+          <a:xfrm>
+            <a:off x="7406740" y="1020283"/>
+            <a:ext cx="1542923" cy="646331"/>
           </a:xfrm>
           <a:prstGeom prst="rect">
             <a:avLst/>
@@ -4200,7 +5253,7 @@
           <a:p>
             <a:r>
               <a:rPr lang="en-US" dirty="0" err="1"/>
-              <a:t>GiaHuy’s</a:t>
+              <a:t>ByAnil’s</a:t>
             </a:r>
             <a:r>
               <a:rPr lang="en-US" dirty="0"/>
@@ -4211,10 +5264,10 @@
       </p:sp>
       <p:sp>
         <p:nvSpPr>
-          <p:cNvPr id="36" name="TextBox 35">
+          <p:cNvPr id="10" name="TextBox 9">
             <a:extLst>
               <a:ext uri="{FF2B5EF4-FFF2-40B4-BE49-F238E27FC236}">
-                <a16:creationId xmlns:a16="http://schemas.microsoft.com/office/drawing/2014/main" id="{0EF2A187-0E41-22B5-D6F9-F99E80D3F9BB}"/>
+                <a16:creationId xmlns:a16="http://schemas.microsoft.com/office/drawing/2014/main" id="{038AB75A-7861-0235-219F-578AB32AE29E}"/>
               </a:ext>
             </a:extLst>
           </p:cNvPr>
@@ -4223,58 +5276,8 @@
         </p:nvSpPr>
         <p:spPr>
           <a:xfrm>
-            <a:off x="1501009" y="5981968"/>
-            <a:ext cx="1526444" cy="646331"/>
-          </a:xfrm>
-          <a:prstGeom prst="rect">
-            <a:avLst/>
-          </a:prstGeom>
-          <a:noFill/>
-          <a:effectLst>
-            <a:outerShdw blurRad="50800" dist="38100" dir="2700000" algn="tl" rotWithShape="0">
-              <a:prstClr val="black">
-                <a:alpha val="40000"/>
-              </a:prstClr>
-            </a:outerShdw>
-          </a:effectLst>
-        </p:spPr>
-        <p:txBody>
-          <a:bodyPr wrap="none" rtlCol="0">
-            <a:spAutoFit/>
-          </a:bodyPr>
-          <a:lstStyle/>
-          <a:p>
-            <a:pPr algn="r"/>
-            <a:r>
-              <a:rPr lang="en-US" dirty="0"/>
-              <a:t>Bottom Lane:</a:t>
-            </a:r>
-          </a:p>
-          <a:p>
-            <a:pPr algn="r"/>
-            <a:r>
-              <a:rPr lang="en-US" dirty="0"/>
-              <a:t>Bun’s Team</a:t>
-            </a:r>
-          </a:p>
-        </p:txBody>
-      </p:sp>
-      <p:sp>
-        <p:nvSpPr>
-          <p:cNvPr id="10" name="TextBox 9">
-            <a:extLst>
-              <a:ext uri="{FF2B5EF4-FFF2-40B4-BE49-F238E27FC236}">
-                <a16:creationId xmlns:a16="http://schemas.microsoft.com/office/drawing/2014/main" id="{6DE9EA09-F463-44EE-3C3A-09ABBE695A49}"/>
-              </a:ext>
-            </a:extLst>
-          </p:cNvPr>
-          <p:cNvSpPr txBox="1"/>
-          <p:nvPr/>
-        </p:nvSpPr>
-        <p:spPr>
-          <a:xfrm>
-            <a:off x="4498513" y="3331222"/>
-            <a:ext cx="1626984" cy="646331"/>
+            <a:off x="4320959" y="3279975"/>
+            <a:ext cx="2752933" cy="646331"/>
           </a:xfrm>
           <a:prstGeom prst="rect">
             <a:avLst/>
@@ -4302,7 +5305,67 @@
           <a:p>
             <a:r>
               <a:rPr lang="en-US" dirty="0"/>
-              <a:t>Draken’s Team</a:t>
+              <a:t>Fluffy, Older, </a:t>
+            </a:r>
+            <a:r>
+              <a:rPr lang="en-US" dirty="0" err="1"/>
+              <a:t>Stellara</a:t>
+            </a:r>
+            <a:r>
+              <a:rPr lang="en-US" dirty="0"/>
+              <a:t>, Bun</a:t>
+            </a:r>
+          </a:p>
+        </p:txBody>
+      </p:sp>
+      <p:sp>
+        <p:nvSpPr>
+          <p:cNvPr id="38" name="TextBox 37">
+            <a:extLst>
+              <a:ext uri="{FF2B5EF4-FFF2-40B4-BE49-F238E27FC236}">
+                <a16:creationId xmlns:a16="http://schemas.microsoft.com/office/drawing/2014/main" id="{DB8301DD-0B9D-BE55-032C-19701116B26C}"/>
+              </a:ext>
+            </a:extLst>
+          </p:cNvPr>
+          <p:cNvSpPr txBox="1"/>
+          <p:nvPr/>
+        </p:nvSpPr>
+        <p:spPr>
+          <a:xfrm>
+            <a:off x="1976748" y="6084157"/>
+            <a:ext cx="1526444" cy="646331"/>
+          </a:xfrm>
+          <a:prstGeom prst="rect">
+            <a:avLst/>
+          </a:prstGeom>
+          <a:noFill/>
+          <a:effectLst>
+            <a:outerShdw blurRad="50800" dist="38100" dir="2700000" algn="tl" rotWithShape="0">
+              <a:prstClr val="black">
+                <a:alpha val="40000"/>
+              </a:prstClr>
+            </a:outerShdw>
+          </a:effectLst>
+        </p:spPr>
+        <p:txBody>
+          <a:bodyPr wrap="none" rtlCol="0">
+            <a:spAutoFit/>
+          </a:bodyPr>
+          <a:lstStyle/>
+          <a:p>
+            <a:r>
+              <a:rPr lang="en-US" dirty="0"/>
+              <a:t>Bottom Lane:</a:t>
+            </a:r>
+          </a:p>
+          <a:p>
+            <a:r>
+              <a:rPr lang="en-US" dirty="0" err="1"/>
+              <a:t>Suntzu</a:t>
+            </a:r>
+            <a:r>
+              <a:rPr lang="en-US" dirty="0"/>
+              <a:t> Team</a:t>
             </a:r>
           </a:p>
         </p:txBody>
@@ -4310,7 +5373,7 @@
     </p:spTree>
     <p:extLst>
       <p:ext uri="{BB962C8B-B14F-4D97-AF65-F5344CB8AC3E}">
-        <p14:creationId xmlns:p14="http://schemas.microsoft.com/office/powerpoint/2010/main" val="2075628722"/>
+        <p14:creationId xmlns:p14="http://schemas.microsoft.com/office/powerpoint/2010/main" val="3146041069"/>
       </p:ext>
     </p:extLst>
   </p:cSld>
@@ -4320,7 +5383,7 @@
 </p:sld>
 </file>
 
-<file path=ppt/slides/slide2.xml><?xml version="1.0" encoding="utf-8"?>
+<file path=ppt/slides/slide3.xml><?xml version="1.0" encoding="utf-8"?>
 <p:sld xmlns:a="http://schemas.openxmlformats.org/drawingml/2006/main" xmlns:r="http://schemas.openxmlformats.org/officeDocument/2006/relationships" xmlns:p="http://schemas.openxmlformats.org/presentationml/2006/main">
   <p:cSld>
     <p:spTree>
@@ -5422,7 +6485,7 @@
 </p:sld>
 </file>
 
-<file path=ppt/slides/slide3.xml><?xml version="1.0" encoding="utf-8"?>
+<file path=ppt/slides/slide4.xml><?xml version="1.0" encoding="utf-8"?>
 <p:sld xmlns:a="http://schemas.openxmlformats.org/drawingml/2006/main" xmlns:r="http://schemas.openxmlformats.org/officeDocument/2006/relationships" xmlns:p="http://schemas.openxmlformats.org/presentationml/2006/main">
   <p:cSld>
     <p:spTree>

</xml_diff>